<commit_message>
added other names to presentation
</commit_message>
<xml_diff>
--- a/Documentation/UnixPresentation.pptx
+++ b/Documentation/UnixPresentation.pptx
@@ -1983,7 +1983,7 @@
           <a:noFill/>
           <a:extLst>
             <a:ext uri="{909E8E84-426E-40dd-AFC4-6F175D3DCCD1}">
-              <a14:hiddenFill xmlns="" xmlns:a14="http://schemas.microsoft.com/office/drawing/2010/main">
+              <a14:hiddenFill xmlns:a14="http://schemas.microsoft.com/office/drawing/2010/main" xmlns="">
                 <a:solidFill>
                   <a:srgbClr val="FFFFFF"/>
                 </a:solidFill>
@@ -2043,7 +2043,7 @@
             </a:ln>
             <a:extLst>
               <a:ext uri="{91240B29-F687-4f45-9708-019B960494DF}">
-                <a14:hiddenLine xmlns="" xmlns:a14="http://schemas.microsoft.com/office/drawing/2010/main" w="9525">
+                <a14:hiddenLine xmlns:a14="http://schemas.microsoft.com/office/drawing/2010/main" xmlns="" w="9525">
                   <a:solidFill>
                     <a:srgbClr val="000000"/>
                   </a:solidFill>
@@ -2133,7 +2133,7 @@
             </a:ln>
             <a:extLst>
               <a:ext uri="{91240B29-F687-4f45-9708-019B960494DF}">
-                <a14:hiddenLine xmlns="" xmlns:a14="http://schemas.microsoft.com/office/drawing/2010/main" w="9525">
+                <a14:hiddenLine xmlns:a14="http://schemas.microsoft.com/office/drawing/2010/main" xmlns="" w="9525">
                   <a:solidFill>
                     <a:srgbClr val="000000"/>
                   </a:solidFill>
@@ -2223,7 +2223,7 @@
             </a:ln>
             <a:extLst>
               <a:ext uri="{91240B29-F687-4f45-9708-019B960494DF}">
-                <a14:hiddenLine xmlns="" xmlns:a14="http://schemas.microsoft.com/office/drawing/2010/main" w="9525">
+                <a14:hiddenLine xmlns:a14="http://schemas.microsoft.com/office/drawing/2010/main" xmlns="" w="9525">
                   <a:solidFill>
                     <a:srgbClr val="000000"/>
                   </a:solidFill>
@@ -2257,7 +2257,7 @@
             </a:ln>
             <a:extLst>
               <a:ext uri="{91240B29-F687-4f45-9708-019B960494DF}">
-                <a14:hiddenLine xmlns="" xmlns:a14="http://schemas.microsoft.com/office/drawing/2010/main" w="9525">
+                <a14:hiddenLine xmlns:a14="http://schemas.microsoft.com/office/drawing/2010/main" xmlns="" w="9525">
                   <a:solidFill>
                     <a:srgbClr val="000000"/>
                   </a:solidFill>
@@ -2347,7 +2347,7 @@
             </a:ln>
             <a:extLst>
               <a:ext uri="{91240B29-F687-4f45-9708-019B960494DF}">
-                <a14:hiddenLine xmlns="" xmlns:a14="http://schemas.microsoft.com/office/drawing/2010/main" w="9525">
+                <a14:hiddenLine xmlns:a14="http://schemas.microsoft.com/office/drawing/2010/main" xmlns="" w="9525">
                   <a:solidFill>
                     <a:srgbClr val="000000"/>
                   </a:solidFill>
@@ -2409,7 +2409,7 @@
             </a:ln>
             <a:extLst>
               <a:ext uri="{91240B29-F687-4f45-9708-019B960494DF}">
-                <a14:hiddenLine xmlns="" xmlns:a14="http://schemas.microsoft.com/office/drawing/2010/main" w="9525">
+                <a14:hiddenLine xmlns:a14="http://schemas.microsoft.com/office/drawing/2010/main" xmlns="" w="9525">
                   <a:solidFill>
                     <a:srgbClr val="000000"/>
                   </a:solidFill>
@@ -2471,7 +2471,7 @@
             </a:ln>
             <a:extLst>
               <a:ext uri="{91240B29-F687-4f45-9708-019B960494DF}">
-                <a14:hiddenLine xmlns="" xmlns:a14="http://schemas.microsoft.com/office/drawing/2010/main" w="9525">
+                <a14:hiddenLine xmlns:a14="http://schemas.microsoft.com/office/drawing/2010/main" xmlns="" w="9525">
                   <a:solidFill>
                     <a:srgbClr val="000000"/>
                   </a:solidFill>
@@ -2561,7 +2561,7 @@
             </a:ln>
             <a:extLst>
               <a:ext uri="{91240B29-F687-4f45-9708-019B960494DF}">
-                <a14:hiddenLine xmlns="" xmlns:a14="http://schemas.microsoft.com/office/drawing/2010/main" w="9525">
+                <a14:hiddenLine xmlns:a14="http://schemas.microsoft.com/office/drawing/2010/main" xmlns="" w="9525">
                   <a:solidFill>
                     <a:srgbClr val="000000"/>
                   </a:solidFill>
@@ -2623,7 +2623,7 @@
             </a:ln>
             <a:extLst>
               <a:ext uri="{91240B29-F687-4f45-9708-019B960494DF}">
-                <a14:hiddenLine xmlns="" xmlns:a14="http://schemas.microsoft.com/office/drawing/2010/main" w="9525">
+                <a14:hiddenLine xmlns:a14="http://schemas.microsoft.com/office/drawing/2010/main" xmlns="" w="9525">
                   <a:solidFill>
                     <a:srgbClr val="000000"/>
                   </a:solidFill>
@@ -2685,7 +2685,7 @@
             </a:ln>
             <a:extLst>
               <a:ext uri="{91240B29-F687-4f45-9708-019B960494DF}">
-                <a14:hiddenLine xmlns="" xmlns:a14="http://schemas.microsoft.com/office/drawing/2010/main" w="9525">
+                <a14:hiddenLine xmlns:a14="http://schemas.microsoft.com/office/drawing/2010/main" xmlns="" w="9525">
                   <a:solidFill>
                     <a:srgbClr val="000000"/>
                   </a:solidFill>
@@ -2775,7 +2775,7 @@
             </a:ln>
             <a:extLst>
               <a:ext uri="{91240B29-F687-4f45-9708-019B960494DF}">
-                <a14:hiddenLine xmlns="" xmlns:a14="http://schemas.microsoft.com/office/drawing/2010/main" w="9525">
+                <a14:hiddenLine xmlns:a14="http://schemas.microsoft.com/office/drawing/2010/main" xmlns="" w="9525">
                   <a:solidFill>
                     <a:srgbClr val="000000"/>
                   </a:solidFill>
@@ -2865,7 +2865,7 @@
             </a:ln>
             <a:extLst>
               <a:ext uri="{91240B29-F687-4f45-9708-019B960494DF}">
-                <a14:hiddenLine xmlns="" xmlns:a14="http://schemas.microsoft.com/office/drawing/2010/main" w="9525">
+                <a14:hiddenLine xmlns:a14="http://schemas.microsoft.com/office/drawing/2010/main" xmlns="" w="9525">
                   <a:solidFill>
                     <a:srgbClr val="000000"/>
                   </a:solidFill>
@@ -2927,7 +2927,7 @@
             </a:ln>
             <a:extLst>
               <a:ext uri="{91240B29-F687-4f45-9708-019B960494DF}">
-                <a14:hiddenLine xmlns="" xmlns:a14="http://schemas.microsoft.com/office/drawing/2010/main" w="9525">
+                <a14:hiddenLine xmlns:a14="http://schemas.microsoft.com/office/drawing/2010/main" xmlns="" w="9525">
                   <a:solidFill>
                     <a:srgbClr val="000000"/>
                   </a:solidFill>
@@ -3037,7 +3037,7 @@
             </a:ln>
             <a:extLst>
               <a:ext uri="{91240B29-F687-4f45-9708-019B960494DF}">
-                <a14:hiddenLine xmlns="" xmlns:a14="http://schemas.microsoft.com/office/drawing/2010/main" w="9525">
+                <a14:hiddenLine xmlns:a14="http://schemas.microsoft.com/office/drawing/2010/main" xmlns="" w="9525">
                   <a:solidFill>
                     <a:srgbClr val="000000"/>
                   </a:solidFill>
@@ -3099,7 +3099,7 @@
             </a:ln>
             <a:extLst>
               <a:ext uri="{91240B29-F687-4f45-9708-019B960494DF}">
-                <a14:hiddenLine xmlns="" xmlns:a14="http://schemas.microsoft.com/office/drawing/2010/main" w="9525">
+                <a14:hiddenLine xmlns:a14="http://schemas.microsoft.com/office/drawing/2010/main" xmlns="" w="9525">
                   <a:solidFill>
                     <a:srgbClr val="000000"/>
                   </a:solidFill>
@@ -3189,7 +3189,7 @@
             </a:ln>
             <a:extLst>
               <a:ext uri="{91240B29-F687-4f45-9708-019B960494DF}">
-                <a14:hiddenLine xmlns="" xmlns:a14="http://schemas.microsoft.com/office/drawing/2010/main" w="9525">
+                <a14:hiddenLine xmlns:a14="http://schemas.microsoft.com/office/drawing/2010/main" xmlns="" w="9525">
                   <a:solidFill>
                     <a:srgbClr val="000000"/>
                   </a:solidFill>
@@ -3279,7 +3279,7 @@
             </a:ln>
             <a:extLst>
               <a:ext uri="{91240B29-F687-4f45-9708-019B960494DF}">
-                <a14:hiddenLine xmlns="" xmlns:a14="http://schemas.microsoft.com/office/drawing/2010/main" w="9525">
+                <a14:hiddenLine xmlns:a14="http://schemas.microsoft.com/office/drawing/2010/main" xmlns="" w="9525">
                   <a:solidFill>
                     <a:srgbClr val="000000"/>
                   </a:solidFill>
@@ -3341,7 +3341,7 @@
             </a:ln>
             <a:extLst>
               <a:ext uri="{91240B29-F687-4f45-9708-019B960494DF}">
-                <a14:hiddenLine xmlns="" xmlns:a14="http://schemas.microsoft.com/office/drawing/2010/main" w="9525">
+                <a14:hiddenLine xmlns:a14="http://schemas.microsoft.com/office/drawing/2010/main" xmlns="" w="9525">
                   <a:solidFill>
                     <a:srgbClr val="000000"/>
                   </a:solidFill>
@@ -3431,7 +3431,7 @@
             </a:ln>
             <a:extLst>
               <a:ext uri="{91240B29-F687-4f45-9708-019B960494DF}">
-                <a14:hiddenLine xmlns="" xmlns:a14="http://schemas.microsoft.com/office/drawing/2010/main" w="9525">
+                <a14:hiddenLine xmlns:a14="http://schemas.microsoft.com/office/drawing/2010/main" xmlns="" w="9525">
                   <a:solidFill>
                     <a:srgbClr val="000000"/>
                   </a:solidFill>
@@ -3521,7 +3521,7 @@
             </a:ln>
             <a:extLst>
               <a:ext uri="{91240B29-F687-4f45-9708-019B960494DF}">
-                <a14:hiddenLine xmlns="" xmlns:a14="http://schemas.microsoft.com/office/drawing/2010/main" w="9525">
+                <a14:hiddenLine xmlns:a14="http://schemas.microsoft.com/office/drawing/2010/main" xmlns="" w="9525">
                   <a:solidFill>
                     <a:srgbClr val="000000"/>
                   </a:solidFill>
@@ -3577,7 +3577,7 @@
             </a:ln>
             <a:extLst>
               <a:ext uri="{91240B29-F687-4f45-9708-019B960494DF}">
-                <a14:hiddenLine xmlns="" xmlns:a14="http://schemas.microsoft.com/office/drawing/2010/main" w="9525">
+                <a14:hiddenLine xmlns:a14="http://schemas.microsoft.com/office/drawing/2010/main" xmlns="" w="9525">
                   <a:solidFill>
                     <a:srgbClr val="000000"/>
                   </a:solidFill>
@@ -3667,7 +3667,7 @@
             </a:ln>
             <a:extLst>
               <a:ext uri="{91240B29-F687-4f45-9708-019B960494DF}">
-                <a14:hiddenLine xmlns="" xmlns:a14="http://schemas.microsoft.com/office/drawing/2010/main" w="9525">
+                <a14:hiddenLine xmlns:a14="http://schemas.microsoft.com/office/drawing/2010/main" xmlns="" w="9525">
                   <a:solidFill>
                     <a:srgbClr val="000000"/>
                   </a:solidFill>
@@ -3723,7 +3723,7 @@
             </a:ln>
             <a:extLst>
               <a:ext uri="{91240B29-F687-4f45-9708-019B960494DF}">
-                <a14:hiddenLine xmlns="" xmlns:a14="http://schemas.microsoft.com/office/drawing/2010/main" w="9525">
+                <a14:hiddenLine xmlns:a14="http://schemas.microsoft.com/office/drawing/2010/main" xmlns="" w="9525">
                   <a:solidFill>
                     <a:srgbClr val="000000"/>
                   </a:solidFill>
@@ -3813,7 +3813,7 @@
             </a:ln>
             <a:extLst>
               <a:ext uri="{91240B29-F687-4f45-9708-019B960494DF}">
-                <a14:hiddenLine xmlns="" xmlns:a14="http://schemas.microsoft.com/office/drawing/2010/main" w="9525">
+                <a14:hiddenLine xmlns:a14="http://schemas.microsoft.com/office/drawing/2010/main" xmlns="" w="9525">
                   <a:solidFill>
                     <a:srgbClr val="000000"/>
                   </a:solidFill>
@@ -3881,7 +3881,7 @@
             </a:ln>
             <a:extLst>
               <a:ext uri="{91240B29-F687-4f45-9708-019B960494DF}">
-                <a14:hiddenLine xmlns="" xmlns:a14="http://schemas.microsoft.com/office/drawing/2010/main" w="9525">
+                <a14:hiddenLine xmlns:a14="http://schemas.microsoft.com/office/drawing/2010/main" xmlns="" w="9525">
                   <a:solidFill>
                     <a:srgbClr val="000000"/>
                   </a:solidFill>
@@ -3971,7 +3971,7 @@
             </a:ln>
             <a:extLst>
               <a:ext uri="{91240B29-F687-4f45-9708-019B960494DF}">
-                <a14:hiddenLine xmlns="" xmlns:a14="http://schemas.microsoft.com/office/drawing/2010/main" w="9525">
+                <a14:hiddenLine xmlns:a14="http://schemas.microsoft.com/office/drawing/2010/main" xmlns="" w="9525">
                   <a:solidFill>
                     <a:srgbClr val="000000"/>
                   </a:solidFill>
@@ -4039,7 +4039,7 @@
             </a:ln>
             <a:extLst>
               <a:ext uri="{91240B29-F687-4f45-9708-019B960494DF}">
-                <a14:hiddenLine xmlns="" xmlns:a14="http://schemas.microsoft.com/office/drawing/2010/main" w="9525">
+                <a14:hiddenLine xmlns:a14="http://schemas.microsoft.com/office/drawing/2010/main" xmlns="" w="9525">
                   <a:solidFill>
                     <a:srgbClr val="000000"/>
                   </a:solidFill>
@@ -4129,7 +4129,7 @@
             </a:ln>
             <a:extLst>
               <a:ext uri="{91240B29-F687-4f45-9708-019B960494DF}">
-                <a14:hiddenLine xmlns="" xmlns:a14="http://schemas.microsoft.com/office/drawing/2010/main" w="9525">
+                <a14:hiddenLine xmlns:a14="http://schemas.microsoft.com/office/drawing/2010/main" xmlns="" w="9525">
                   <a:solidFill>
                     <a:srgbClr val="000000"/>
                   </a:solidFill>
@@ -4163,7 +4163,7 @@
             </a:ln>
             <a:extLst>
               <a:ext uri="{91240B29-F687-4f45-9708-019B960494DF}">
-                <a14:hiddenLine xmlns="" xmlns:a14="http://schemas.microsoft.com/office/drawing/2010/main" w="9525">
+                <a14:hiddenLine xmlns:a14="http://schemas.microsoft.com/office/drawing/2010/main" xmlns="" w="9525">
                   <a:solidFill>
                     <a:srgbClr val="000000"/>
                   </a:solidFill>
@@ -4253,7 +4253,7 @@
             </a:ln>
             <a:extLst>
               <a:ext uri="{91240B29-F687-4f45-9708-019B960494DF}">
-                <a14:hiddenLine xmlns="" xmlns:a14="http://schemas.microsoft.com/office/drawing/2010/main" w="9525">
+                <a14:hiddenLine xmlns:a14="http://schemas.microsoft.com/office/drawing/2010/main" xmlns="" w="9525">
                   <a:solidFill>
                     <a:srgbClr val="000000"/>
                   </a:solidFill>
@@ -4315,7 +4315,7 @@
             </a:ln>
             <a:extLst>
               <a:ext uri="{91240B29-F687-4f45-9708-019B960494DF}">
-                <a14:hiddenLine xmlns="" xmlns:a14="http://schemas.microsoft.com/office/drawing/2010/main" w="9525">
+                <a14:hiddenLine xmlns:a14="http://schemas.microsoft.com/office/drawing/2010/main" xmlns="" w="9525">
                   <a:solidFill>
                     <a:srgbClr val="000000"/>
                   </a:solidFill>
@@ -4377,7 +4377,7 @@
             </a:ln>
             <a:extLst>
               <a:ext uri="{91240B29-F687-4f45-9708-019B960494DF}">
-                <a14:hiddenLine xmlns="" xmlns:a14="http://schemas.microsoft.com/office/drawing/2010/main" w="9525">
+                <a14:hiddenLine xmlns:a14="http://schemas.microsoft.com/office/drawing/2010/main" xmlns="" w="9525">
                   <a:solidFill>
                     <a:srgbClr val="000000"/>
                   </a:solidFill>
@@ -4467,7 +4467,7 @@
             </a:ln>
             <a:extLst>
               <a:ext uri="{91240B29-F687-4f45-9708-019B960494DF}">
-                <a14:hiddenLine xmlns="" xmlns:a14="http://schemas.microsoft.com/office/drawing/2010/main" w="9525">
+                <a14:hiddenLine xmlns:a14="http://schemas.microsoft.com/office/drawing/2010/main" xmlns="" w="9525">
                   <a:solidFill>
                     <a:srgbClr val="000000"/>
                   </a:solidFill>
@@ -4535,7 +4535,7 @@
             </a:ln>
             <a:extLst>
               <a:ext uri="{91240B29-F687-4f45-9708-019B960494DF}">
-                <a14:hiddenLine xmlns="" xmlns:a14="http://schemas.microsoft.com/office/drawing/2010/main" w="9525">
+                <a14:hiddenLine xmlns:a14="http://schemas.microsoft.com/office/drawing/2010/main" xmlns="" w="9525">
                   <a:solidFill>
                     <a:srgbClr val="000000"/>
                   </a:solidFill>
@@ -4597,7 +4597,7 @@
             </a:ln>
             <a:extLst>
               <a:ext uri="{91240B29-F687-4f45-9708-019B960494DF}">
-                <a14:hiddenLine xmlns="" xmlns:a14="http://schemas.microsoft.com/office/drawing/2010/main" w="9525">
+                <a14:hiddenLine xmlns:a14="http://schemas.microsoft.com/office/drawing/2010/main" xmlns="" w="9525">
                   <a:solidFill>
                     <a:srgbClr val="000000"/>
                   </a:solidFill>
@@ -4687,7 +4687,7 @@
             </a:ln>
             <a:extLst>
               <a:ext uri="{91240B29-F687-4f45-9708-019B960494DF}">
-                <a14:hiddenLine xmlns="" xmlns:a14="http://schemas.microsoft.com/office/drawing/2010/main" w="9525">
+                <a14:hiddenLine xmlns:a14="http://schemas.microsoft.com/office/drawing/2010/main" xmlns="" w="9525">
                   <a:solidFill>
                     <a:srgbClr val="000000"/>
                   </a:solidFill>
@@ -4749,7 +4749,7 @@
             </a:ln>
             <a:extLst>
               <a:ext uri="{91240B29-F687-4f45-9708-019B960494DF}">
-                <a14:hiddenLine xmlns="" xmlns:a14="http://schemas.microsoft.com/office/drawing/2010/main" w="9525">
+                <a14:hiddenLine xmlns:a14="http://schemas.microsoft.com/office/drawing/2010/main" xmlns="" w="9525">
                   <a:solidFill>
                     <a:srgbClr val="000000"/>
                   </a:solidFill>
@@ -4839,7 +4839,7 @@
             </a:ln>
             <a:extLst>
               <a:ext uri="{91240B29-F687-4f45-9708-019B960494DF}">
-                <a14:hiddenLine xmlns="" xmlns:a14="http://schemas.microsoft.com/office/drawing/2010/main" w="9525">
+                <a14:hiddenLine xmlns:a14="http://schemas.microsoft.com/office/drawing/2010/main" xmlns="" w="9525">
                   <a:solidFill>
                     <a:srgbClr val="000000"/>
                   </a:solidFill>
@@ -4901,7 +4901,7 @@
             </a:ln>
             <a:extLst>
               <a:ext uri="{91240B29-F687-4f45-9708-019B960494DF}">
-                <a14:hiddenLine xmlns="" xmlns:a14="http://schemas.microsoft.com/office/drawing/2010/main" w="9525">
+                <a14:hiddenLine xmlns:a14="http://schemas.microsoft.com/office/drawing/2010/main" xmlns="" w="9525">
                   <a:solidFill>
                     <a:srgbClr val="000000"/>
                   </a:solidFill>
@@ -4991,7 +4991,7 @@
             </a:ln>
             <a:extLst>
               <a:ext uri="{91240B29-F687-4f45-9708-019B960494DF}">
-                <a14:hiddenLine xmlns="" xmlns:a14="http://schemas.microsoft.com/office/drawing/2010/main" w="9525">
+                <a14:hiddenLine xmlns:a14="http://schemas.microsoft.com/office/drawing/2010/main" xmlns="" w="9525">
                   <a:solidFill>
                     <a:srgbClr val="000000"/>
                   </a:solidFill>
@@ -5025,7 +5025,7 @@
             </a:ln>
             <a:extLst>
               <a:ext uri="{91240B29-F687-4f45-9708-019B960494DF}">
-                <a14:hiddenLine xmlns="" xmlns:a14="http://schemas.microsoft.com/office/drawing/2010/main" w="9525">
+                <a14:hiddenLine xmlns:a14="http://schemas.microsoft.com/office/drawing/2010/main" xmlns="" w="9525">
                   <a:solidFill>
                     <a:srgbClr val="000000"/>
                   </a:solidFill>
@@ -5090,7 +5090,7 @@
             </a:ln>
             <a:extLst>
               <a:ext uri="{91240B29-F687-4f45-9708-019B960494DF}">
-                <a14:hiddenLine xmlns="" xmlns:a14="http://schemas.microsoft.com/office/drawing/2010/main" w="9525">
+                <a14:hiddenLine xmlns:a14="http://schemas.microsoft.com/office/drawing/2010/main" xmlns="" w="9525">
                   <a:solidFill>
                     <a:srgbClr val="000000"/>
                   </a:solidFill>
@@ -5180,7 +5180,7 @@
             </a:ln>
             <a:extLst>
               <a:ext uri="{91240B29-F687-4f45-9708-019B960494DF}">
-                <a14:hiddenLine xmlns="" xmlns:a14="http://schemas.microsoft.com/office/drawing/2010/main" w="9525">
+                <a14:hiddenLine xmlns:a14="http://schemas.microsoft.com/office/drawing/2010/main" xmlns="" w="9525">
                   <a:solidFill>
                     <a:srgbClr val="000000"/>
                   </a:solidFill>
@@ -5242,7 +5242,7 @@
             </a:ln>
             <a:extLst>
               <a:ext uri="{91240B29-F687-4f45-9708-019B960494DF}">
-                <a14:hiddenLine xmlns="" xmlns:a14="http://schemas.microsoft.com/office/drawing/2010/main" w="9525">
+                <a14:hiddenLine xmlns:a14="http://schemas.microsoft.com/office/drawing/2010/main" xmlns="" w="9525">
                   <a:solidFill>
                     <a:srgbClr val="000000"/>
                   </a:solidFill>
@@ -5332,7 +5332,7 @@
             </a:ln>
             <a:extLst>
               <a:ext uri="{91240B29-F687-4f45-9708-019B960494DF}">
-                <a14:hiddenLine xmlns="" xmlns:a14="http://schemas.microsoft.com/office/drawing/2010/main" w="9525">
+                <a14:hiddenLine xmlns:a14="http://schemas.microsoft.com/office/drawing/2010/main" xmlns="" w="9525">
                   <a:solidFill>
                     <a:srgbClr val="000000"/>
                   </a:solidFill>
@@ -5422,7 +5422,7 @@
             </a:ln>
             <a:extLst>
               <a:ext uri="{91240B29-F687-4f45-9708-019B960494DF}">
-                <a14:hiddenLine xmlns="" xmlns:a14="http://schemas.microsoft.com/office/drawing/2010/main" w="9525">
+                <a14:hiddenLine xmlns:a14="http://schemas.microsoft.com/office/drawing/2010/main" xmlns="" w="9525">
                   <a:solidFill>
                     <a:srgbClr val="000000"/>
                   </a:solidFill>
@@ -5487,7 +5487,7 @@
             </a:ln>
             <a:extLst>
               <a:ext uri="{91240B29-F687-4f45-9708-019B960494DF}">
-                <a14:hiddenLine xmlns="" xmlns:a14="http://schemas.microsoft.com/office/drawing/2010/main" w="9525">
+                <a14:hiddenLine xmlns:a14="http://schemas.microsoft.com/office/drawing/2010/main" xmlns="" w="9525">
                   <a:solidFill>
                     <a:srgbClr val="000000"/>
                   </a:solidFill>
@@ -5549,7 +5549,7 @@
             </a:ln>
             <a:extLst>
               <a:ext uri="{91240B29-F687-4f45-9708-019B960494DF}">
-                <a14:hiddenLine xmlns="" xmlns:a14="http://schemas.microsoft.com/office/drawing/2010/main" w="9525">
+                <a14:hiddenLine xmlns:a14="http://schemas.microsoft.com/office/drawing/2010/main" xmlns="" w="9525">
                   <a:solidFill>
                     <a:srgbClr val="000000"/>
                   </a:solidFill>
@@ -5639,7 +5639,7 @@
             </a:ln>
             <a:extLst>
               <a:ext uri="{91240B29-F687-4f45-9708-019B960494DF}">
-                <a14:hiddenLine xmlns="" xmlns:a14="http://schemas.microsoft.com/office/drawing/2010/main" w="9525">
+                <a14:hiddenLine xmlns:a14="http://schemas.microsoft.com/office/drawing/2010/main" xmlns="" w="9525">
                   <a:solidFill>
                     <a:srgbClr val="000000"/>
                   </a:solidFill>
@@ -5729,7 +5729,7 @@
             </a:ln>
             <a:extLst>
               <a:ext uri="{91240B29-F687-4f45-9708-019B960494DF}">
-                <a14:hiddenLine xmlns="" xmlns:a14="http://schemas.microsoft.com/office/drawing/2010/main" w="9525">
+                <a14:hiddenLine xmlns:a14="http://schemas.microsoft.com/office/drawing/2010/main" xmlns="" w="9525">
                   <a:solidFill>
                     <a:srgbClr val="000000"/>
                   </a:solidFill>
@@ -5791,7 +5791,7 @@
             </a:ln>
             <a:extLst>
               <a:ext uri="{91240B29-F687-4f45-9708-019B960494DF}">
-                <a14:hiddenLine xmlns="" xmlns:a14="http://schemas.microsoft.com/office/drawing/2010/main" w="9525">
+                <a14:hiddenLine xmlns:a14="http://schemas.microsoft.com/office/drawing/2010/main" xmlns="" w="9525">
                   <a:solidFill>
                     <a:srgbClr val="000000"/>
                   </a:solidFill>
@@ -5911,7 +5911,7 @@
             </a:ln>
             <a:extLst>
               <a:ext uri="{91240B29-F687-4f45-9708-019B960494DF}">
-                <a14:hiddenLine xmlns="" xmlns:a14="http://schemas.microsoft.com/office/drawing/2010/main" w="9525">
+                <a14:hiddenLine xmlns:a14="http://schemas.microsoft.com/office/drawing/2010/main" xmlns="" w="9525">
                   <a:solidFill>
                     <a:srgbClr val="000000"/>
                   </a:solidFill>
@@ -5979,7 +5979,7 @@
             </a:ln>
             <a:extLst>
               <a:ext uri="{91240B29-F687-4f45-9708-019B960494DF}">
-                <a14:hiddenLine xmlns="" xmlns:a14="http://schemas.microsoft.com/office/drawing/2010/main" w="9525">
+                <a14:hiddenLine xmlns:a14="http://schemas.microsoft.com/office/drawing/2010/main" xmlns="" w="9525">
                   <a:solidFill>
                     <a:srgbClr val="000000"/>
                   </a:solidFill>
@@ -6069,7 +6069,7 @@
             </a:ln>
             <a:extLst>
               <a:ext uri="{91240B29-F687-4f45-9708-019B960494DF}">
-                <a14:hiddenLine xmlns="" xmlns:a14="http://schemas.microsoft.com/office/drawing/2010/main" w="9525">
+                <a14:hiddenLine xmlns:a14="http://schemas.microsoft.com/office/drawing/2010/main" xmlns="" w="9525">
                   <a:solidFill>
                     <a:srgbClr val="000000"/>
                   </a:solidFill>
@@ -10927,7 +10927,7 @@
           <a:noFill/>
           <a:extLst>
             <a:ext uri="{909E8E84-426E-40dd-AFC4-6F175D3DCCD1}">
-              <a14:hiddenFill xmlns="" xmlns:a14="http://schemas.microsoft.com/office/drawing/2010/main">
+              <a14:hiddenFill xmlns:a14="http://schemas.microsoft.com/office/drawing/2010/main" xmlns="">
                 <a:solidFill>
                   <a:srgbClr val="FFFFFF"/>
                 </a:solidFill>
@@ -11001,7 +11001,7 @@
               </a:ln>
               <a:extLst>
                 <a:ext uri="{91240B29-F687-4f45-9708-019B960494DF}">
-                  <a14:hiddenLine xmlns="" xmlns:a14="http://schemas.microsoft.com/office/drawing/2010/main" w="9525">
+                  <a14:hiddenLine xmlns:a14="http://schemas.microsoft.com/office/drawing/2010/main" xmlns="" w="9525">
                     <a:solidFill>
                       <a:srgbClr val="000000"/>
                     </a:solidFill>
@@ -11091,7 +11091,7 @@
               </a:ln>
               <a:extLst>
                 <a:ext uri="{91240B29-F687-4f45-9708-019B960494DF}">
-                  <a14:hiddenLine xmlns="" xmlns:a14="http://schemas.microsoft.com/office/drawing/2010/main" w="9525">
+                  <a14:hiddenLine xmlns:a14="http://schemas.microsoft.com/office/drawing/2010/main" xmlns="" w="9525">
                     <a:solidFill>
                       <a:srgbClr val="000000"/>
                     </a:solidFill>
@@ -11181,7 +11181,7 @@
               </a:ln>
               <a:extLst>
                 <a:ext uri="{91240B29-F687-4f45-9708-019B960494DF}">
-                  <a14:hiddenLine xmlns="" xmlns:a14="http://schemas.microsoft.com/office/drawing/2010/main" w="9525">
+                  <a14:hiddenLine xmlns:a14="http://schemas.microsoft.com/office/drawing/2010/main" xmlns="" w="9525">
                     <a:solidFill>
                       <a:srgbClr val="000000"/>
                     </a:solidFill>
@@ -11243,7 +11243,7 @@
               </a:ln>
               <a:extLst>
                 <a:ext uri="{91240B29-F687-4f45-9708-019B960494DF}">
-                  <a14:hiddenLine xmlns="" xmlns:a14="http://schemas.microsoft.com/office/drawing/2010/main" w="9525">
+                  <a14:hiddenLine xmlns:a14="http://schemas.microsoft.com/office/drawing/2010/main" xmlns="" w="9525">
                     <a:solidFill>
                       <a:srgbClr val="000000"/>
                     </a:solidFill>
@@ -11333,7 +11333,7 @@
               </a:ln>
               <a:extLst>
                 <a:ext uri="{91240B29-F687-4f45-9708-019B960494DF}">
-                  <a14:hiddenLine xmlns="" xmlns:a14="http://schemas.microsoft.com/office/drawing/2010/main" w="9525">
+                  <a14:hiddenLine xmlns:a14="http://schemas.microsoft.com/office/drawing/2010/main" xmlns="" w="9525">
                     <a:solidFill>
                       <a:srgbClr val="000000"/>
                     </a:solidFill>
@@ -11395,7 +11395,7 @@
               </a:ln>
               <a:extLst>
                 <a:ext uri="{91240B29-F687-4f45-9708-019B960494DF}">
-                  <a14:hiddenLine xmlns="" xmlns:a14="http://schemas.microsoft.com/office/drawing/2010/main" w="9525">
+                  <a14:hiddenLine xmlns:a14="http://schemas.microsoft.com/office/drawing/2010/main" xmlns="" w="9525">
                     <a:solidFill>
                       <a:srgbClr val="000000"/>
                     </a:solidFill>
@@ -11457,7 +11457,7 @@
               </a:ln>
               <a:extLst>
                 <a:ext uri="{91240B29-F687-4f45-9708-019B960494DF}">
-                  <a14:hiddenLine xmlns="" xmlns:a14="http://schemas.microsoft.com/office/drawing/2010/main" w="9525">
+                  <a14:hiddenLine xmlns:a14="http://schemas.microsoft.com/office/drawing/2010/main" xmlns="" w="9525">
                     <a:solidFill>
                       <a:srgbClr val="000000"/>
                     </a:solidFill>
@@ -11547,7 +11547,7 @@
               </a:ln>
               <a:extLst>
                 <a:ext uri="{91240B29-F687-4f45-9708-019B960494DF}">
-                  <a14:hiddenLine xmlns="" xmlns:a14="http://schemas.microsoft.com/office/drawing/2010/main" w="9525">
+                  <a14:hiddenLine xmlns:a14="http://schemas.microsoft.com/office/drawing/2010/main" xmlns="" w="9525">
                     <a:solidFill>
                       <a:srgbClr val="000000"/>
                     </a:solidFill>
@@ -11637,7 +11637,7 @@
               </a:ln>
               <a:extLst>
                 <a:ext uri="{91240B29-F687-4f45-9708-019B960494DF}">
-                  <a14:hiddenLine xmlns="" xmlns:a14="http://schemas.microsoft.com/office/drawing/2010/main" w="9525">
+                  <a14:hiddenLine xmlns:a14="http://schemas.microsoft.com/office/drawing/2010/main" xmlns="" w="9525">
                     <a:solidFill>
                       <a:srgbClr val="000000"/>
                     </a:solidFill>
@@ -11699,7 +11699,7 @@
               </a:ln>
               <a:extLst>
                 <a:ext uri="{91240B29-F687-4f45-9708-019B960494DF}">
-                  <a14:hiddenLine xmlns="" xmlns:a14="http://schemas.microsoft.com/office/drawing/2010/main" w="9525">
+                  <a14:hiddenLine xmlns:a14="http://schemas.microsoft.com/office/drawing/2010/main" xmlns="" w="9525">
                     <a:solidFill>
                       <a:srgbClr val="000000"/>
                     </a:solidFill>
@@ -11809,7 +11809,7 @@
               </a:ln>
               <a:extLst>
                 <a:ext uri="{91240B29-F687-4f45-9708-019B960494DF}">
-                  <a14:hiddenLine xmlns="" xmlns:a14="http://schemas.microsoft.com/office/drawing/2010/main" w="9525">
+                  <a14:hiddenLine xmlns:a14="http://schemas.microsoft.com/office/drawing/2010/main" xmlns="" w="9525">
                     <a:solidFill>
                       <a:srgbClr val="000000"/>
                     </a:solidFill>
@@ -11893,7 +11893,7 @@
               </a:ln>
               <a:extLst>
                 <a:ext uri="{91240B29-F687-4f45-9708-019B960494DF}">
-                  <a14:hiddenLine xmlns="" xmlns:a14="http://schemas.microsoft.com/office/drawing/2010/main" w="9525">
+                  <a14:hiddenLine xmlns:a14="http://schemas.microsoft.com/office/drawing/2010/main" xmlns="" w="9525">
                     <a:solidFill>
                       <a:srgbClr val="000000"/>
                     </a:solidFill>
@@ -11955,7 +11955,7 @@
               </a:ln>
               <a:extLst>
                 <a:ext uri="{91240B29-F687-4f45-9708-019B960494DF}">
-                  <a14:hiddenLine xmlns="" xmlns:a14="http://schemas.microsoft.com/office/drawing/2010/main" w="9525">
+                  <a14:hiddenLine xmlns:a14="http://schemas.microsoft.com/office/drawing/2010/main" xmlns="" w="9525">
                     <a:solidFill>
                       <a:srgbClr val="000000"/>
                     </a:solidFill>
@@ -12017,7 +12017,7 @@
               </a:ln>
               <a:extLst>
                 <a:ext uri="{91240B29-F687-4f45-9708-019B960494DF}">
-                  <a14:hiddenLine xmlns="" xmlns:a14="http://schemas.microsoft.com/office/drawing/2010/main" w="9525">
+                  <a14:hiddenLine xmlns:a14="http://schemas.microsoft.com/office/drawing/2010/main" xmlns="" w="9525">
                     <a:solidFill>
                       <a:srgbClr val="000000"/>
                     </a:solidFill>
@@ -12107,7 +12107,7 @@
               </a:ln>
               <a:extLst>
                 <a:ext uri="{91240B29-F687-4f45-9708-019B960494DF}">
-                  <a14:hiddenLine xmlns="" xmlns:a14="http://schemas.microsoft.com/office/drawing/2010/main" w="9525">
+                  <a14:hiddenLine xmlns:a14="http://schemas.microsoft.com/office/drawing/2010/main" xmlns="" w="9525">
                     <a:solidFill>
                       <a:srgbClr val="000000"/>
                     </a:solidFill>
@@ -12141,7 +12141,7 @@
               </a:ln>
               <a:extLst>
                 <a:ext uri="{91240B29-F687-4f45-9708-019B960494DF}">
-                  <a14:hiddenLine xmlns="" xmlns:a14="http://schemas.microsoft.com/office/drawing/2010/main" w="9525">
+                  <a14:hiddenLine xmlns:a14="http://schemas.microsoft.com/office/drawing/2010/main" xmlns="" w="9525">
                     <a:solidFill>
                       <a:srgbClr val="000000"/>
                     </a:solidFill>
@@ -12206,7 +12206,7 @@
               </a:ln>
               <a:extLst>
                 <a:ext uri="{91240B29-F687-4f45-9708-019B960494DF}">
-                  <a14:hiddenLine xmlns="" xmlns:a14="http://schemas.microsoft.com/office/drawing/2010/main" w="9525">
+                  <a14:hiddenLine xmlns:a14="http://schemas.microsoft.com/office/drawing/2010/main" xmlns="" w="9525">
                     <a:solidFill>
                       <a:srgbClr val="000000"/>
                     </a:solidFill>
@@ -12296,7 +12296,7 @@
               </a:ln>
               <a:extLst>
                 <a:ext uri="{91240B29-F687-4f45-9708-019B960494DF}">
-                  <a14:hiddenLine xmlns="" xmlns:a14="http://schemas.microsoft.com/office/drawing/2010/main" w="9525">
+                  <a14:hiddenLine xmlns:a14="http://schemas.microsoft.com/office/drawing/2010/main" xmlns="" w="9525">
                     <a:solidFill>
                       <a:srgbClr val="000000"/>
                     </a:solidFill>
@@ -12358,7 +12358,7 @@
               </a:ln>
               <a:extLst>
                 <a:ext uri="{91240B29-F687-4f45-9708-019B960494DF}">
-                  <a14:hiddenLine xmlns="" xmlns:a14="http://schemas.microsoft.com/office/drawing/2010/main" w="9525">
+                  <a14:hiddenLine xmlns:a14="http://schemas.microsoft.com/office/drawing/2010/main" xmlns="" w="9525">
                     <a:solidFill>
                       <a:srgbClr val="000000"/>
                     </a:solidFill>
@@ -12448,7 +12448,7 @@
               </a:ln>
               <a:extLst>
                 <a:ext uri="{91240B29-F687-4f45-9708-019B960494DF}">
-                  <a14:hiddenLine xmlns="" xmlns:a14="http://schemas.microsoft.com/office/drawing/2010/main" w="9525">
+                  <a14:hiddenLine xmlns:a14="http://schemas.microsoft.com/office/drawing/2010/main" xmlns="" w="9525">
                     <a:solidFill>
                       <a:srgbClr val="000000"/>
                     </a:solidFill>
@@ -12513,7 +12513,7 @@
               </a:ln>
               <a:extLst>
                 <a:ext uri="{91240B29-F687-4f45-9708-019B960494DF}">
-                  <a14:hiddenLine xmlns="" xmlns:a14="http://schemas.microsoft.com/office/drawing/2010/main" w="9525">
+                  <a14:hiddenLine xmlns:a14="http://schemas.microsoft.com/office/drawing/2010/main" xmlns="" w="9525">
                     <a:solidFill>
                       <a:srgbClr val="000000"/>
                     </a:solidFill>
@@ -12575,7 +12575,7 @@
               </a:ln>
               <a:extLst>
                 <a:ext uri="{91240B29-F687-4f45-9708-019B960494DF}">
-                  <a14:hiddenLine xmlns="" xmlns:a14="http://schemas.microsoft.com/office/drawing/2010/main" w="9525">
+                  <a14:hiddenLine xmlns:a14="http://schemas.microsoft.com/office/drawing/2010/main" xmlns="" w="9525">
                     <a:solidFill>
                       <a:srgbClr val="000000"/>
                     </a:solidFill>
@@ -12665,7 +12665,7 @@
               </a:ln>
               <a:extLst>
                 <a:ext uri="{91240B29-F687-4f45-9708-019B960494DF}">
-                  <a14:hiddenLine xmlns="" xmlns:a14="http://schemas.microsoft.com/office/drawing/2010/main" w="9525">
+                  <a14:hiddenLine xmlns:a14="http://schemas.microsoft.com/office/drawing/2010/main" xmlns="" w="9525">
                     <a:solidFill>
                       <a:srgbClr val="000000"/>
                     </a:solidFill>
@@ -12755,7 +12755,7 @@
               </a:ln>
               <a:extLst>
                 <a:ext uri="{91240B29-F687-4f45-9708-019B960494DF}">
-                  <a14:hiddenLine xmlns="" xmlns:a14="http://schemas.microsoft.com/office/drawing/2010/main" w="9525">
+                  <a14:hiddenLine xmlns:a14="http://schemas.microsoft.com/office/drawing/2010/main" xmlns="" w="9525">
                     <a:solidFill>
                       <a:srgbClr val="000000"/>
                     </a:solidFill>
@@ -12820,7 +12820,7 @@
               </a:ln>
               <a:extLst>
                 <a:ext uri="{91240B29-F687-4f45-9708-019B960494DF}">
-                  <a14:hiddenLine xmlns="" xmlns:a14="http://schemas.microsoft.com/office/drawing/2010/main" w="9525">
+                  <a14:hiddenLine xmlns:a14="http://schemas.microsoft.com/office/drawing/2010/main" xmlns="" w="9525">
                     <a:solidFill>
                       <a:srgbClr val="000000"/>
                     </a:solidFill>
@@ -12940,7 +12940,7 @@
               </a:ln>
               <a:extLst>
                 <a:ext uri="{91240B29-F687-4f45-9708-019B960494DF}">
-                  <a14:hiddenLine xmlns="" xmlns:a14="http://schemas.microsoft.com/office/drawing/2010/main" w="9525">
+                  <a14:hiddenLine xmlns:a14="http://schemas.microsoft.com/office/drawing/2010/main" xmlns="" w="9525">
                     <a:solidFill>
                       <a:srgbClr val="000000"/>
                     </a:solidFill>
@@ -13038,7 +13038,7 @@
               </a:ln>
               <a:extLst>
                 <a:ext uri="{91240B29-F687-4f45-9708-019B960494DF}">
-                  <a14:hiddenLine xmlns="" xmlns:a14="http://schemas.microsoft.com/office/drawing/2010/main" w="9525">
+                  <a14:hiddenLine xmlns:a14="http://schemas.microsoft.com/office/drawing/2010/main" xmlns="" w="9525">
                     <a:solidFill>
                       <a:srgbClr val="000000"/>
                     </a:solidFill>
@@ -13153,7 +13153,7 @@
               </a:ln>
               <a:extLst>
                 <a:ext uri="{91240B29-F687-4f45-9708-019B960494DF}">
-                  <a14:hiddenLine xmlns="" xmlns:a14="http://schemas.microsoft.com/office/drawing/2010/main" w="9525">
+                  <a14:hiddenLine xmlns:a14="http://schemas.microsoft.com/office/drawing/2010/main" xmlns="" w="9525">
                     <a:solidFill>
                       <a:srgbClr val="000000"/>
                     </a:solidFill>
@@ -13243,7 +13243,7 @@
               </a:ln>
               <a:extLst>
                 <a:ext uri="{91240B29-F687-4f45-9708-019B960494DF}">
-                  <a14:hiddenLine xmlns="" xmlns:a14="http://schemas.microsoft.com/office/drawing/2010/main" w="9525">
+                  <a14:hiddenLine xmlns:a14="http://schemas.microsoft.com/office/drawing/2010/main" xmlns="" w="9525">
                     <a:solidFill>
                       <a:srgbClr val="000000"/>
                     </a:solidFill>
@@ -13308,7 +13308,7 @@
               </a:ln>
               <a:extLst>
                 <a:ext uri="{91240B29-F687-4f45-9708-019B960494DF}">
-                  <a14:hiddenLine xmlns="" xmlns:a14="http://schemas.microsoft.com/office/drawing/2010/main" w="9525">
+                  <a14:hiddenLine xmlns:a14="http://schemas.microsoft.com/office/drawing/2010/main" xmlns="" w="9525">
                     <a:solidFill>
                       <a:srgbClr val="000000"/>
                     </a:solidFill>
@@ -13398,7 +13398,7 @@
               </a:ln>
               <a:extLst>
                 <a:ext uri="{91240B29-F687-4f45-9708-019B960494DF}">
-                  <a14:hiddenLine xmlns="" xmlns:a14="http://schemas.microsoft.com/office/drawing/2010/main" w="9525">
+                  <a14:hiddenLine xmlns:a14="http://schemas.microsoft.com/office/drawing/2010/main" xmlns="" w="9525">
                     <a:solidFill>
                       <a:srgbClr val="000000"/>
                     </a:solidFill>
@@ -13466,7 +13466,7 @@
               </a:ln>
               <a:extLst>
                 <a:ext uri="{91240B29-F687-4f45-9708-019B960494DF}">
-                  <a14:hiddenLine xmlns="" xmlns:a14="http://schemas.microsoft.com/office/drawing/2010/main" w="9525">
+                  <a14:hiddenLine xmlns:a14="http://schemas.microsoft.com/office/drawing/2010/main" xmlns="" w="9525">
                     <a:solidFill>
                       <a:srgbClr val="000000"/>
                     </a:solidFill>
@@ -13556,7 +13556,7 @@
               </a:ln>
               <a:extLst>
                 <a:ext uri="{91240B29-F687-4f45-9708-019B960494DF}">
-                  <a14:hiddenLine xmlns="" xmlns:a14="http://schemas.microsoft.com/office/drawing/2010/main" w="9525">
+                  <a14:hiddenLine xmlns:a14="http://schemas.microsoft.com/office/drawing/2010/main" xmlns="" w="9525">
                     <a:solidFill>
                       <a:srgbClr val="000000"/>
                     </a:solidFill>
@@ -13624,7 +13624,7 @@
               </a:ln>
               <a:extLst>
                 <a:ext uri="{91240B29-F687-4f45-9708-019B960494DF}">
-                  <a14:hiddenLine xmlns="" xmlns:a14="http://schemas.microsoft.com/office/drawing/2010/main" w="9525">
+                  <a14:hiddenLine xmlns:a14="http://schemas.microsoft.com/office/drawing/2010/main" xmlns="" w="9525">
                     <a:solidFill>
                       <a:srgbClr val="000000"/>
                     </a:solidFill>
@@ -13714,7 +13714,7 @@
               </a:ln>
               <a:extLst>
                 <a:ext uri="{91240B29-F687-4f45-9708-019B960494DF}">
-                  <a14:hiddenLine xmlns="" xmlns:a14="http://schemas.microsoft.com/office/drawing/2010/main" w="9525">
+                  <a14:hiddenLine xmlns:a14="http://schemas.microsoft.com/office/drawing/2010/main" xmlns="" w="9525">
                     <a:solidFill>
                       <a:srgbClr val="000000"/>
                     </a:solidFill>
@@ -13748,7 +13748,7 @@
               </a:ln>
               <a:extLst>
                 <a:ext uri="{91240B29-F687-4f45-9708-019B960494DF}">
-                  <a14:hiddenLine xmlns="" xmlns:a14="http://schemas.microsoft.com/office/drawing/2010/main" w="9525">
+                  <a14:hiddenLine xmlns:a14="http://schemas.microsoft.com/office/drawing/2010/main" xmlns="" w="9525">
                     <a:solidFill>
                       <a:srgbClr val="000000"/>
                     </a:solidFill>
@@ -15509,7 +15509,7 @@
                 <a:ea typeface="Calibri Light" panose="020F0302020204030204" pitchFamily="34" charset="0"/>
                 <a:cs typeface="Calibri Light" panose="020F0302020204030204" pitchFamily="34" charset="0"/>
               </a:rPr>
-              <a:t>				name: “INSERT NAME HERE”</a:t>
+              <a:t>				name: “Rachel Herron”</a:t>
             </a:r>
           </a:p>
           <a:p>
@@ -15606,7 +15606,7 @@
                 <a:ea typeface="Calibri Light" panose="020F0302020204030204" pitchFamily="34" charset="0"/>
                 <a:cs typeface="Calibri Light" panose="020F0302020204030204" pitchFamily="34" charset="0"/>
               </a:rPr>
-              <a:t>				name: “INSERT NAME HERE”</a:t>
+              <a:t>				name: “Helene Rousseau”</a:t>
             </a:r>
           </a:p>
           <a:p>

</xml_diff>